<commit_message>
fix the Center's name in presentation ppt templates
</commit_message>
<xml_diff>
--- a/templates/CARRE/CARRE-Presentation-ppt/CARRE-Presentation-blue.pptx
+++ b/templates/CARRE/CARRE-Presentation-ppt/CARRE-Presentation-blue.pptx
@@ -217,7 +217,7 @@
           <a:p>
             <a:fld id="{3763DFAF-06DC-43B1-BBC9-0429973D07E9}" type="datetimeFigureOut">
               <a:rPr lang="en-US" smtClean="0"/>
-              <a:t>11/22/25</a:t>
+              <a:t>10/7/26</a:t>
             </a:fld>
             <a:endParaRPr lang="en-US"/>
           </a:p>
@@ -2008,7 +2008,21 @@
                 <a:latin typeface="Arial" panose="020B0604020202020204" pitchFamily="34" charset="0"/>
                 <a:cs typeface="Arial" panose="020B0604020202020204" pitchFamily="34" charset="0"/>
               </a:rPr>
-              <a:t>Center for Advancing the Radiation Resilience of Electrons (CARRE)</a:t>
+              <a:t>Center for Advancing the Radiation Resilience </a:t>
+            </a:r>
+            <a:r>
+              <a:rPr lang="en-US" sz="1800">
+                <a:latin typeface="Arial" panose="020B0604020202020204" pitchFamily="34" charset="0"/>
+                <a:cs typeface="Arial" panose="020B0604020202020204" pitchFamily="34" charset="0"/>
+              </a:rPr>
+              <a:t>of Electronics </a:t>
+            </a:r>
+            <a:r>
+              <a:rPr lang="en-US" sz="1800" dirty="0">
+                <a:latin typeface="Arial" panose="020B0604020202020204" pitchFamily="34" charset="0"/>
+                <a:cs typeface="Arial" panose="020B0604020202020204" pitchFamily="34" charset="0"/>
+              </a:rPr>
+              <a:t>(CARRE)</a:t>
             </a:r>
           </a:p>
           <a:p>

</xml_diff>